<commit_message>
Presentation Mouhassib Pro : retrait du nombre de caisses (multiposte)
Co-Authored-By: Claude Opus 5.5 <noreply@anthropic.com>
Claude-Session: https://claude.ai/code/session_0173KNAxAYGcdE4tydTXD6sA
</commit_message>
<xml_diff>
--- a/public/presentations/mouhassib-pro/Mouhassib-Pro-presentation-ar.pptx
+++ b/public/presentations/mouhassib-pro/Mouhassib-Pro-presentation-ar.pptx
@@ -122,14 +122,14 @@
   <p:extLst>
     <p:ext uri="{521415D9-36F7-43E2-AB2F-B90AF26B5E84}">
       <p14:sectionLst xmlns:p14="http://schemas.microsoft.com/office/powerpoint/2010/main">
-        <p14:section name="التقديم" id="{5a0020c4-d516-8b61-e0be-4b0d740fa9d3}">
+        <p14:section name="التقديم" id="{30d4a047-5597-ed70-29c8-ccf8e21ba792}">
           <p14:sldIdLst>
             <p14:sldId id="256"/>
             <p14:sldId id="257"/>
             <p14:sldId id="258"/>
           </p14:sldIdLst>
         </p14:section>
-        <p14:section name="في العمل اليومي" id="{cf30687c-5a88-369d-822c-83f5307bd20e}">
+        <p14:section name="في العمل اليومي" id="{c82da113-e314-87ff-9705-91443ad9693b}">
           <p14:sldIdLst>
             <p14:sldId id="259"/>
             <p14:sldId id="260"/>
@@ -137,7 +137,7 @@
             <p14:sldId id="262"/>
           </p14:sldIdLst>
         </p14:section>
-        <p14:section name="التسيير" id="{f618b4b4-af47-307a-e735-81143efb78f3}">
+        <p14:section name="التسيير" id="{f55254ca-648c-1651-79a5-c39933196b47}">
           <p14:sldIdLst>
             <p14:sldId id="263"/>
             <p14:sldId id="264"/>
@@ -145,7 +145,7 @@
             <p14:sldId id="266"/>
           </p14:sldIdLst>
         </p14:section>
-        <p14:section name="اختبار التحمّل" id="{623e8111-5e89-7f2d-cd84-49b3cb010dd1}">
+        <p14:section name="اختبار التحمّل" id="{57957c9a-8e84-51b0-e72f-1b5cf5d38b1a}">
           <p14:sldIdLst>
             <p14:sldId id="267"/>
             <p14:sldId id="268"/>
@@ -153,7 +153,7 @@
             <p14:sldId id="270"/>
           </p14:sldIdLst>
         </p14:section>
-        <p14:section name="اتصلوا بنا" id="{c4026b3c-a213-5776-4725-33be3f44fc12}">
+        <p14:section name="اتصلوا بنا" id="{0237ce36-458e-9ae7-8688-f7b6b7fe40b9}">
           <p14:sldIdLst>
             <p14:sldId id="271"/>
           </p14:sldIdLst>
@@ -193,7 +193,7 @@
                 </a:solidFill>
                 <a:latin typeface="+mn-lt"/>
               </a:rPr>
-              <a:t>المبيعات المؤكَّدة في الدقيقة (10 صناديق)</a:t>
+              <a:t>المبيعات المؤكَّدة في الدقيقة (كل الصناديق معاً)</a:t>
             </a:r>
           </a:p>
         </c:rich>
@@ -304,7 +304,7 @@
                 <c:ptCount val="4"/>
                 <c:lvl>
                   <c:pt idx="0">
-                    <c:v>الحاجة الفعلية: 10 صناديق في ساعة الذروة</c:v>
+                    <c:v>الحاجة الفعلية لمتجر كبير في ساعة الذروة</c:v>
                   </c:pt>
                   <c:pt idx="1">
                     <c:v>القدرة عبر واي فاي ضعيف</c:v>
@@ -1425,7 +1425,7 @@
           <a:p>
             <a:r>
               <a:rPr lang="en-US" dirty="0"/>
-              <a:t>حاكينا متجراً كبيراً: 10 صناديق تبيع في الوقت نفسه على خادم PostgreSQL، بينما يطّلع المسيّر على تقاريره كل 5 ثوانٍ. خادم الاختبار متواضع: معالجان وذاكرة 7 جيغابايت، مثل حاسوب مكتبي عادي.</a:t>
+              <a:t>حاكينا متجراً كبيراً متعدد المراكز: عدة صناديق تبيع في الوقت نفسه على خادم PostgreSQL، بينما يطّلع المسيّر على تقاريره كل 5 ثوانٍ. خادم الاختبار متواضع: معالجان وذاكرة 7 جيغابايت، مثل حاسوب مكتبي عادي.</a:t>
             </a:r>
             <a:endParaRPr lang="en-US" dirty="0"/>
           </a:p>
@@ -1513,7 +1513,7 @@
           <a:p>
             <a:r>
               <a:rPr lang="en-US" dirty="0"/>
-              <a:t>حتى على حاسوب متواضع، يؤكّد الخادم أكثر من 6600 عملية بيع في الدقيقة عبر الكابل، بينما يحتاج متجر كبير بعشرة صناديق في ساعة الذروة إلى نحو ثلاثين. أي أن الخادم لا يستعمل حتى 1% من قدرته. وفي 14370 عملية بيع تجريبية، لا خطأ واحد: المخزون والصندوق والمحاسبة كلها صحيحة.</a:t>
+              <a:t>حتى على حاسوب متواضع، يؤكّد الخادم أكثر من 6600 عملية بيع في الدقيقة عبر الكابل، بينما يحتاج متجر كبير متعدد المراكز في ساعة الذروة إلى نحو ثلاثين. أي أن الخادم لا يستعمل حتى 1% من قدرته. وفي 14370 عملية بيع تجريبية، لا خطأ واحد: المخزون والصندوق والمحاسبة كلها صحيحة.</a:t>
             </a:r>
             <a:endParaRPr lang="en-US" dirty="0"/>
           </a:p>
@@ -1689,7 +1689,7 @@
           <a:p>
             <a:r>
               <a:rPr lang="en-US" dirty="0"/>
-              <a:t>باختصار: لعشرة صناديق، الخادم كافٍ بشكل كبير. الخطر الحقيقي هو واي فاي غير مستقر. ومن هنا توصياتنا: الكابل، وجهاز الحماية من انقطاع الكهرباء، والنسخ الاحتياطية. أُجري هذا الاختبار على قاعدة تحاكي عمل البرنامج، وسنعيده بمحاسب برو نفسه.</a:t>
+              <a:t>باختصار: لمتجر متعدد المراكز، الخادم كافٍ بشكل كبير. الخطر الحقيقي هو واي فاي غير مستقر. ومن هنا توصياتنا: الكابل، وجهاز الحماية من انقطاع الكهرباء، والنسخ الاحتياطية. أُجري هذا الاختبار على قاعدة تحاكي عمل البرنامج، وسنعيده بمحاسب برو نفسه.</a:t>
             </a:r>
             <a:endParaRPr lang="en-US" dirty="0"/>
           </a:p>
@@ -4788,7 +4788,7 @@
                   <a:schemeClr val="tx2"/>
                 </a:solidFill>
               </a:rPr>
-              <a:t>اختبار التحمّل: 10 صناديق في الوقت نفسه</a:t>
+              <a:t>اختبار التحمّل: عدة صناديق في الوقت نفسه</a:t>
             </a:r>
             <a:endParaRPr lang="ar-SA" sz="2800" dirty="0"/>
           </a:p>
@@ -4837,8 +4837,8 @@
         </p:blipFill>
         <p:spPr>
           <a:xfrm>
-            <a:off x="8458200" y="1207008"/>
-            <a:ext cx="182880" cy="182880"/>
+            <a:off x="8311896" y="1197864"/>
+            <a:ext cx="219456" cy="219456"/>
           </a:xfrm>
           <a:prstGeom prst="rect">
             <a:avLst/>
@@ -4847,43 +4847,7 @@
       </p:pic>
       <p:sp>
         <p:nvSpPr>
-          <p:cNvPr id="5" name="Numéro caisse"/>
-          <p:cNvSpPr txBox="1"/>
-          <p:nvPr/>
-        </p:nvSpPr>
-        <p:spPr>
-          <a:xfrm>
-            <a:off x="8174736" y="1097280"/>
-            <a:ext cx="237744" cy="411480"/>
-          </a:xfrm>
-          <a:prstGeom prst="rect">
-            <a:avLst/>
-          </a:prstGeom>
-          <a:noFill/>
-          <a:ln/>
-        </p:spPr>
-        <p:txBody>
-          <a:bodyPr wrap="square" lIns="0" tIns="0" rIns="0" bIns="0" rtlCol="0" anchor="ctr"/>
-          <a:lstStyle/>
-          <a:p>
-            <a:pPr algn="r" indent="0" marL="0">
-              <a:buNone/>
-            </a:pPr>
-            <a:r>
-              <a:rPr lang="ar-SA" altLang="en-US" sz="1100" b="1" dirty="0">
-                <a:solidFill>
-                  <a:schemeClr val="tx2"/>
-                </a:solidFill>
-              </a:rPr>
-              <a:t>1</a:t>
-            </a:r>
-            <a:endParaRPr lang="ar-SA" sz="1100" dirty="0"/>
-          </a:p>
-        </p:txBody>
-      </p:sp>
-      <p:sp>
-        <p:nvSpPr>
-          <p:cNvPr id="6" name="Caisse 2"/>
+          <p:cNvPr id="5" name="Caisse 2"/>
           <p:cNvSpPr/>
           <p:nvPr/>
         </p:nvSpPr>
@@ -4910,7 +4874,7 @@
       </p:sp>
       <p:pic>
         <p:nvPicPr>
-          <p:cNvPr id="7" name="Caisse icône" descr="preencoded.png">    </p:cNvPr>
+          <p:cNvPr id="6" name="Caisse icône" descr="preencoded.png">    </p:cNvPr>
           <p:cNvPicPr>
             <a:picLocks noChangeAspect="1"/>
           </p:cNvPicPr>
@@ -4924,8 +4888,8 @@
         </p:blipFill>
         <p:spPr>
           <a:xfrm>
-            <a:off x="7854696" y="1207008"/>
-            <a:ext cx="182880" cy="182880"/>
+            <a:off x="7708392" y="1197864"/>
+            <a:ext cx="219456" cy="219456"/>
           </a:xfrm>
           <a:prstGeom prst="rect">
             <a:avLst/>
@@ -4934,43 +4898,7 @@
       </p:pic>
       <p:sp>
         <p:nvSpPr>
-          <p:cNvPr id="8" name="Numéro caisse"/>
-          <p:cNvSpPr txBox="1"/>
-          <p:nvPr/>
-        </p:nvSpPr>
-        <p:spPr>
-          <a:xfrm>
-            <a:off x="7571232" y="1097280"/>
-            <a:ext cx="237744" cy="411480"/>
-          </a:xfrm>
-          <a:prstGeom prst="rect">
-            <a:avLst/>
-          </a:prstGeom>
-          <a:noFill/>
-          <a:ln/>
-        </p:spPr>
-        <p:txBody>
-          <a:bodyPr wrap="square" lIns="0" tIns="0" rIns="0" bIns="0" rtlCol="0" anchor="ctr"/>
-          <a:lstStyle/>
-          <a:p>
-            <a:pPr algn="r" indent="0" marL="0">
-              <a:buNone/>
-            </a:pPr>
-            <a:r>
-              <a:rPr lang="ar-SA" altLang="en-US" sz="1100" b="1" dirty="0">
-                <a:solidFill>
-                  <a:schemeClr val="tx2"/>
-                </a:solidFill>
-              </a:rPr>
-              <a:t>2</a:t>
-            </a:r>
-            <a:endParaRPr lang="ar-SA" sz="1100" dirty="0"/>
-          </a:p>
-        </p:txBody>
-      </p:sp>
-      <p:sp>
-        <p:nvSpPr>
-          <p:cNvPr id="9" name="Caisse 3"/>
+          <p:cNvPr id="7" name="Caisse 3"/>
           <p:cNvSpPr/>
           <p:nvPr/>
         </p:nvSpPr>
@@ -4997,7 +4925,7 @@
       </p:sp>
       <p:pic>
         <p:nvPicPr>
-          <p:cNvPr id="10" name="Caisse icône" descr="preencoded.png">    </p:cNvPr>
+          <p:cNvPr id="8" name="Caisse icône" descr="preencoded.png">    </p:cNvPr>
           <p:cNvPicPr>
             <a:picLocks noChangeAspect="1"/>
           </p:cNvPicPr>
@@ -5011,8 +4939,8 @@
         </p:blipFill>
         <p:spPr>
           <a:xfrm>
-            <a:off x="7251192" y="1207008"/>
-            <a:ext cx="182880" cy="182880"/>
+            <a:off x="7104888" y="1197864"/>
+            <a:ext cx="219456" cy="219456"/>
           </a:xfrm>
           <a:prstGeom prst="rect">
             <a:avLst/>
@@ -5021,43 +4949,7 @@
       </p:pic>
       <p:sp>
         <p:nvSpPr>
-          <p:cNvPr id="11" name="Numéro caisse"/>
-          <p:cNvSpPr txBox="1"/>
-          <p:nvPr/>
-        </p:nvSpPr>
-        <p:spPr>
-          <a:xfrm>
-            <a:off x="6967728" y="1097280"/>
-            <a:ext cx="237744" cy="411480"/>
-          </a:xfrm>
-          <a:prstGeom prst="rect">
-            <a:avLst/>
-          </a:prstGeom>
-          <a:noFill/>
-          <a:ln/>
-        </p:spPr>
-        <p:txBody>
-          <a:bodyPr wrap="square" lIns="0" tIns="0" rIns="0" bIns="0" rtlCol="0" anchor="ctr"/>
-          <a:lstStyle/>
-          <a:p>
-            <a:pPr algn="r" indent="0" marL="0">
-              <a:buNone/>
-            </a:pPr>
-            <a:r>
-              <a:rPr lang="ar-SA" altLang="en-US" sz="1100" b="1" dirty="0">
-                <a:solidFill>
-                  <a:schemeClr val="tx2"/>
-                </a:solidFill>
-              </a:rPr>
-              <a:t>3</a:t>
-            </a:r>
-            <a:endParaRPr lang="ar-SA" sz="1100" dirty="0"/>
-          </a:p>
-        </p:txBody>
-      </p:sp>
-      <p:sp>
-        <p:nvSpPr>
-          <p:cNvPr id="12" name="Caisse 4"/>
+          <p:cNvPr id="9" name="Caisse 4"/>
           <p:cNvSpPr/>
           <p:nvPr/>
         </p:nvSpPr>
@@ -5084,7 +4976,7 @@
       </p:sp>
       <p:pic>
         <p:nvPicPr>
-          <p:cNvPr id="13" name="Caisse icône" descr="preencoded.png">    </p:cNvPr>
+          <p:cNvPr id="10" name="Caisse icône" descr="preencoded.png">    </p:cNvPr>
           <p:cNvPicPr>
             <a:picLocks noChangeAspect="1"/>
           </p:cNvPicPr>
@@ -5098,8 +4990,8 @@
         </p:blipFill>
         <p:spPr>
           <a:xfrm>
-            <a:off x="6647688" y="1207008"/>
-            <a:ext cx="182880" cy="182880"/>
+            <a:off x="6501384" y="1197864"/>
+            <a:ext cx="219456" cy="219456"/>
           </a:xfrm>
           <a:prstGeom prst="rect">
             <a:avLst/>
@@ -5108,43 +5000,7 @@
       </p:pic>
       <p:sp>
         <p:nvSpPr>
-          <p:cNvPr id="14" name="Numéro caisse"/>
-          <p:cNvSpPr txBox="1"/>
-          <p:nvPr/>
-        </p:nvSpPr>
-        <p:spPr>
-          <a:xfrm>
-            <a:off x="6364224" y="1097280"/>
-            <a:ext cx="237744" cy="411480"/>
-          </a:xfrm>
-          <a:prstGeom prst="rect">
-            <a:avLst/>
-          </a:prstGeom>
-          <a:noFill/>
-          <a:ln/>
-        </p:spPr>
-        <p:txBody>
-          <a:bodyPr wrap="square" lIns="0" tIns="0" rIns="0" bIns="0" rtlCol="0" anchor="ctr"/>
-          <a:lstStyle/>
-          <a:p>
-            <a:pPr algn="r" indent="0" marL="0">
-              <a:buNone/>
-            </a:pPr>
-            <a:r>
-              <a:rPr lang="ar-SA" altLang="en-US" sz="1100" b="1" dirty="0">
-                <a:solidFill>
-                  <a:schemeClr val="tx2"/>
-                </a:solidFill>
-              </a:rPr>
-              <a:t>4</a:t>
-            </a:r>
-            <a:endParaRPr lang="ar-SA" sz="1100" dirty="0"/>
-          </a:p>
-        </p:txBody>
-      </p:sp>
-      <p:sp>
-        <p:nvSpPr>
-          <p:cNvPr id="15" name="Caisse 5"/>
+          <p:cNvPr id="11" name="Caisse 5"/>
           <p:cNvSpPr/>
           <p:nvPr/>
         </p:nvSpPr>
@@ -5171,7 +5027,7 @@
       </p:sp>
       <p:pic>
         <p:nvPicPr>
-          <p:cNvPr id="16" name="Caisse icône" descr="preencoded.png">    </p:cNvPr>
+          <p:cNvPr id="12" name="Caisse icône" descr="preencoded.png">    </p:cNvPr>
           <p:cNvPicPr>
             <a:picLocks noChangeAspect="1"/>
           </p:cNvPicPr>
@@ -5185,8 +5041,8 @@
         </p:blipFill>
         <p:spPr>
           <a:xfrm>
-            <a:off x="6044184" y="1207008"/>
-            <a:ext cx="182880" cy="182880"/>
+            <a:off x="5897880" y="1197864"/>
+            <a:ext cx="219456" cy="219456"/>
           </a:xfrm>
           <a:prstGeom prst="rect">
             <a:avLst/>
@@ -5195,43 +5051,7 @@
       </p:pic>
       <p:sp>
         <p:nvSpPr>
-          <p:cNvPr id="17" name="Numéro caisse"/>
-          <p:cNvSpPr txBox="1"/>
-          <p:nvPr/>
-        </p:nvSpPr>
-        <p:spPr>
-          <a:xfrm>
-            <a:off x="5760720" y="1097280"/>
-            <a:ext cx="237744" cy="411480"/>
-          </a:xfrm>
-          <a:prstGeom prst="rect">
-            <a:avLst/>
-          </a:prstGeom>
-          <a:noFill/>
-          <a:ln/>
-        </p:spPr>
-        <p:txBody>
-          <a:bodyPr wrap="square" lIns="0" tIns="0" rIns="0" bIns="0" rtlCol="0" anchor="ctr"/>
-          <a:lstStyle/>
-          <a:p>
-            <a:pPr algn="r" indent="0" marL="0">
-              <a:buNone/>
-            </a:pPr>
-            <a:r>
-              <a:rPr lang="ar-SA" altLang="en-US" sz="1100" b="1" dirty="0">
-                <a:solidFill>
-                  <a:schemeClr val="tx2"/>
-                </a:solidFill>
-              </a:rPr>
-              <a:t>5</a:t>
-            </a:r>
-            <a:endParaRPr lang="ar-SA" sz="1100" dirty="0"/>
-          </a:p>
-        </p:txBody>
-      </p:sp>
-      <p:sp>
-        <p:nvSpPr>
-          <p:cNvPr id="18" name="Caisse 6"/>
+          <p:cNvPr id="13" name="Caisse 6"/>
           <p:cNvSpPr/>
           <p:nvPr/>
         </p:nvSpPr>
@@ -5258,7 +5078,7 @@
       </p:sp>
       <p:pic>
         <p:nvPicPr>
-          <p:cNvPr id="19" name="Caisse icône" descr="preencoded.png">    </p:cNvPr>
+          <p:cNvPr id="14" name="Caisse icône" descr="preencoded.png">    </p:cNvPr>
           <p:cNvPicPr>
             <a:picLocks noChangeAspect="1"/>
           </p:cNvPicPr>
@@ -5272,8 +5092,8 @@
         </p:blipFill>
         <p:spPr>
           <a:xfrm>
-            <a:off x="8458200" y="1709928"/>
-            <a:ext cx="182880" cy="182880"/>
+            <a:off x="8311896" y="1700784"/>
+            <a:ext cx="219456" cy="219456"/>
           </a:xfrm>
           <a:prstGeom prst="rect">
             <a:avLst/>
@@ -5282,43 +5102,7 @@
       </p:pic>
       <p:sp>
         <p:nvSpPr>
-          <p:cNvPr id="20" name="Numéro caisse"/>
-          <p:cNvSpPr txBox="1"/>
-          <p:nvPr/>
-        </p:nvSpPr>
-        <p:spPr>
-          <a:xfrm>
-            <a:off x="8174736" y="1600200"/>
-            <a:ext cx="237744" cy="411480"/>
-          </a:xfrm>
-          <a:prstGeom prst="rect">
-            <a:avLst/>
-          </a:prstGeom>
-          <a:noFill/>
-          <a:ln/>
-        </p:spPr>
-        <p:txBody>
-          <a:bodyPr wrap="square" lIns="0" tIns="0" rIns="0" bIns="0" rtlCol="0" anchor="ctr"/>
-          <a:lstStyle/>
-          <a:p>
-            <a:pPr algn="r" indent="0" marL="0">
-              <a:buNone/>
-            </a:pPr>
-            <a:r>
-              <a:rPr lang="ar-SA" altLang="en-US" sz="1100" b="1" dirty="0">
-                <a:solidFill>
-                  <a:schemeClr val="tx2"/>
-                </a:solidFill>
-              </a:rPr>
-              <a:t>6</a:t>
-            </a:r>
-            <a:endParaRPr lang="ar-SA" sz="1100" dirty="0"/>
-          </a:p>
-        </p:txBody>
-      </p:sp>
-      <p:sp>
-        <p:nvSpPr>
-          <p:cNvPr id="21" name="Caisse 7"/>
+          <p:cNvPr id="15" name="Caisse 7"/>
           <p:cNvSpPr/>
           <p:nvPr/>
         </p:nvSpPr>
@@ -5345,7 +5129,7 @@
       </p:sp>
       <p:pic>
         <p:nvPicPr>
-          <p:cNvPr id="22" name="Caisse icône" descr="preencoded.png">    </p:cNvPr>
+          <p:cNvPr id="16" name="Caisse icône" descr="preencoded.png">    </p:cNvPr>
           <p:cNvPicPr>
             <a:picLocks noChangeAspect="1"/>
           </p:cNvPicPr>
@@ -5359,8 +5143,8 @@
         </p:blipFill>
         <p:spPr>
           <a:xfrm>
-            <a:off x="7854696" y="1709928"/>
-            <a:ext cx="182880" cy="182880"/>
+            <a:off x="7708392" y="1700784"/>
+            <a:ext cx="219456" cy="219456"/>
           </a:xfrm>
           <a:prstGeom prst="rect">
             <a:avLst/>
@@ -5369,43 +5153,7 @@
       </p:pic>
       <p:sp>
         <p:nvSpPr>
-          <p:cNvPr id="23" name="Numéro caisse"/>
-          <p:cNvSpPr txBox="1"/>
-          <p:nvPr/>
-        </p:nvSpPr>
-        <p:spPr>
-          <a:xfrm>
-            <a:off x="7571232" y="1600200"/>
-            <a:ext cx="237744" cy="411480"/>
-          </a:xfrm>
-          <a:prstGeom prst="rect">
-            <a:avLst/>
-          </a:prstGeom>
-          <a:noFill/>
-          <a:ln/>
-        </p:spPr>
-        <p:txBody>
-          <a:bodyPr wrap="square" lIns="0" tIns="0" rIns="0" bIns="0" rtlCol="0" anchor="ctr"/>
-          <a:lstStyle/>
-          <a:p>
-            <a:pPr algn="r" indent="0" marL="0">
-              <a:buNone/>
-            </a:pPr>
-            <a:r>
-              <a:rPr lang="ar-SA" altLang="en-US" sz="1100" b="1" dirty="0">
-                <a:solidFill>
-                  <a:schemeClr val="tx2"/>
-                </a:solidFill>
-              </a:rPr>
-              <a:t>7</a:t>
-            </a:r>
-            <a:endParaRPr lang="ar-SA" sz="1100" dirty="0"/>
-          </a:p>
-        </p:txBody>
-      </p:sp>
-      <p:sp>
-        <p:nvSpPr>
-          <p:cNvPr id="24" name="Caisse 8"/>
+          <p:cNvPr id="17" name="Caisse 8"/>
           <p:cNvSpPr/>
           <p:nvPr/>
         </p:nvSpPr>
@@ -5432,7 +5180,7 @@
       </p:sp>
       <p:pic>
         <p:nvPicPr>
-          <p:cNvPr id="25" name="Caisse icône" descr="preencoded.png">    </p:cNvPr>
+          <p:cNvPr id="18" name="Caisse icône" descr="preencoded.png">    </p:cNvPr>
           <p:cNvPicPr>
             <a:picLocks noChangeAspect="1"/>
           </p:cNvPicPr>
@@ -5446,8 +5194,8 @@
         </p:blipFill>
         <p:spPr>
           <a:xfrm>
-            <a:off x="7251192" y="1709928"/>
-            <a:ext cx="182880" cy="182880"/>
+            <a:off x="7104888" y="1700784"/>
+            <a:ext cx="219456" cy="219456"/>
           </a:xfrm>
           <a:prstGeom prst="rect">
             <a:avLst/>
@@ -5456,43 +5204,7 @@
       </p:pic>
       <p:sp>
         <p:nvSpPr>
-          <p:cNvPr id="26" name="Numéro caisse"/>
-          <p:cNvSpPr txBox="1"/>
-          <p:nvPr/>
-        </p:nvSpPr>
-        <p:spPr>
-          <a:xfrm>
-            <a:off x="6967728" y="1600200"/>
-            <a:ext cx="237744" cy="411480"/>
-          </a:xfrm>
-          <a:prstGeom prst="rect">
-            <a:avLst/>
-          </a:prstGeom>
-          <a:noFill/>
-          <a:ln/>
-        </p:spPr>
-        <p:txBody>
-          <a:bodyPr wrap="square" lIns="0" tIns="0" rIns="0" bIns="0" rtlCol="0" anchor="ctr"/>
-          <a:lstStyle/>
-          <a:p>
-            <a:pPr algn="r" indent="0" marL="0">
-              <a:buNone/>
-            </a:pPr>
-            <a:r>
-              <a:rPr lang="ar-SA" altLang="en-US" sz="1100" b="1" dirty="0">
-                <a:solidFill>
-                  <a:schemeClr val="tx2"/>
-                </a:solidFill>
-              </a:rPr>
-              <a:t>8</a:t>
-            </a:r>
-            <a:endParaRPr lang="ar-SA" sz="1100" dirty="0"/>
-          </a:p>
-        </p:txBody>
-      </p:sp>
-      <p:sp>
-        <p:nvSpPr>
-          <p:cNvPr id="27" name="Caisse 9"/>
+          <p:cNvPr id="19" name="Caisse 9"/>
           <p:cNvSpPr/>
           <p:nvPr/>
         </p:nvSpPr>
@@ -5519,7 +5231,7 @@
       </p:sp>
       <p:pic>
         <p:nvPicPr>
-          <p:cNvPr id="28" name="Caisse icône" descr="preencoded.png">    </p:cNvPr>
+          <p:cNvPr id="20" name="Caisse icône" descr="preencoded.png">    </p:cNvPr>
           <p:cNvPicPr>
             <a:picLocks noChangeAspect="1"/>
           </p:cNvPicPr>
@@ -5533,8 +5245,8 @@
         </p:blipFill>
         <p:spPr>
           <a:xfrm>
-            <a:off x="6647688" y="1709928"/>
-            <a:ext cx="182880" cy="182880"/>
+            <a:off x="6501384" y="1700784"/>
+            <a:ext cx="219456" cy="219456"/>
           </a:xfrm>
           <a:prstGeom prst="rect">
             <a:avLst/>
@@ -5543,43 +5255,7 @@
       </p:pic>
       <p:sp>
         <p:nvSpPr>
-          <p:cNvPr id="29" name="Numéro caisse"/>
-          <p:cNvSpPr txBox="1"/>
-          <p:nvPr/>
-        </p:nvSpPr>
-        <p:spPr>
-          <a:xfrm>
-            <a:off x="6364224" y="1600200"/>
-            <a:ext cx="237744" cy="411480"/>
-          </a:xfrm>
-          <a:prstGeom prst="rect">
-            <a:avLst/>
-          </a:prstGeom>
-          <a:noFill/>
-          <a:ln/>
-        </p:spPr>
-        <p:txBody>
-          <a:bodyPr wrap="square" lIns="0" tIns="0" rIns="0" bIns="0" rtlCol="0" anchor="ctr"/>
-          <a:lstStyle/>
-          <a:p>
-            <a:pPr algn="r" indent="0" marL="0">
-              <a:buNone/>
-            </a:pPr>
-            <a:r>
-              <a:rPr lang="ar-SA" altLang="en-US" sz="1100" b="1" dirty="0">
-                <a:solidFill>
-                  <a:schemeClr val="tx2"/>
-                </a:solidFill>
-              </a:rPr>
-              <a:t>9</a:t>
-            </a:r>
-            <a:endParaRPr lang="ar-SA" sz="1100" dirty="0"/>
-          </a:p>
-        </p:txBody>
-      </p:sp>
-      <p:sp>
-        <p:nvSpPr>
-          <p:cNvPr id="30" name="Caisse 10"/>
+          <p:cNvPr id="21" name="Caisse 10"/>
           <p:cNvSpPr/>
           <p:nvPr/>
         </p:nvSpPr>
@@ -5606,7 +5282,7 @@
       </p:sp>
       <p:pic>
         <p:nvPicPr>
-          <p:cNvPr id="31" name="Caisse icône" descr="preencoded.png">    </p:cNvPr>
+          <p:cNvPr id="22" name="Caisse icône" descr="preencoded.png">    </p:cNvPr>
           <p:cNvPicPr>
             <a:picLocks noChangeAspect="1"/>
           </p:cNvPicPr>
@@ -5620,8 +5296,8 @@
         </p:blipFill>
         <p:spPr>
           <a:xfrm>
-            <a:off x="6044184" y="1709928"/>
-            <a:ext cx="182880" cy="182880"/>
+            <a:off x="5897880" y="1700784"/>
+            <a:ext cx="219456" cy="219456"/>
           </a:xfrm>
           <a:prstGeom prst="rect">
             <a:avLst/>
@@ -5630,43 +5306,7 @@
       </p:pic>
       <p:sp>
         <p:nvSpPr>
-          <p:cNvPr id="32" name="Numéro caisse"/>
-          <p:cNvSpPr txBox="1"/>
-          <p:nvPr/>
-        </p:nvSpPr>
-        <p:spPr>
-          <a:xfrm>
-            <a:off x="5760720" y="1600200"/>
-            <a:ext cx="237744" cy="411480"/>
-          </a:xfrm>
-          <a:prstGeom prst="rect">
-            <a:avLst/>
-          </a:prstGeom>
-          <a:noFill/>
-          <a:ln/>
-        </p:spPr>
-        <p:txBody>
-          <a:bodyPr wrap="square" lIns="0" tIns="0" rIns="0" bIns="0" rtlCol="0" anchor="ctr"/>
-          <a:lstStyle/>
-          <a:p>
-            <a:pPr algn="r" indent="0" marL="0">
-              <a:buNone/>
-            </a:pPr>
-            <a:r>
-              <a:rPr lang="ar-SA" altLang="en-US" sz="1100" b="1" dirty="0">
-                <a:solidFill>
-                  <a:schemeClr val="tx2"/>
-                </a:solidFill>
-              </a:rPr>
-              <a:t>10</a:t>
-            </a:r>
-            <a:endParaRPr lang="ar-SA" sz="1100" dirty="0"/>
-          </a:p>
-        </p:txBody>
-      </p:sp>
-      <p:sp>
-        <p:nvSpPr>
-          <p:cNvPr id="33" name="Liaison caisses"/>
+          <p:cNvPr id="23" name="Liaison caisses"/>
           <p:cNvSpPr/>
           <p:nvPr/>
         </p:nvSpPr>
@@ -5689,14 +5329,14 @@
       </p:sp>
       <p:sp>
         <p:nvSpPr>
-          <p:cNvPr id="34" name="Légende caisses"/>
+          <p:cNvPr id="24" name="Légende caisses"/>
           <p:cNvSpPr txBox="1"/>
           <p:nvPr/>
         </p:nvSpPr>
         <p:spPr>
           <a:xfrm>
-            <a:off x="6053328" y="2029968"/>
-            <a:ext cx="1097280" cy="320040"/>
+            <a:off x="5687568" y="2029968"/>
+            <a:ext cx="1463040" cy="320040"/>
           </a:xfrm>
           <a:prstGeom prst="rect">
             <a:avLst/>
@@ -5717,7 +5357,7 @@
                   <a:schemeClr val="accent5"/>
                 </a:solidFill>
               </a:rPr>
-              <a:t>10 صناديق</a:t>
+              <a:t>صناديق عبر الشبكة</a:t>
             </a:r>
             <a:endParaRPr lang="ar-SA" sz="1100" dirty="0"/>
           </a:p>
@@ -5725,7 +5365,7 @@
       </p:sp>
       <p:sp>
         <p:nvSpPr>
-          <p:cNvPr id="35" name="Switch"/>
+          <p:cNvPr id="25" name="Switch"/>
           <p:cNvSpPr/>
           <p:nvPr/>
         </p:nvSpPr>
@@ -5752,7 +5392,7 @@
       </p:sp>
       <p:pic>
         <p:nvPicPr>
-          <p:cNvPr id="36" name="Switch icône" descr="preencoded.png">    </p:cNvPr>
+          <p:cNvPr id="26" name="Switch icône" descr="preencoded.png">    </p:cNvPr>
           <p:cNvPicPr>
             <a:picLocks noChangeAspect="1"/>
           </p:cNvPicPr>
@@ -5776,7 +5416,7 @@
       </p:pic>
       <p:sp>
         <p:nvSpPr>
-          <p:cNvPr id="37" name="Switch texte"/>
+          <p:cNvPr id="27" name="Switch texte"/>
           <p:cNvSpPr txBox="1"/>
           <p:nvPr/>
         </p:nvSpPr>
@@ -5812,7 +5452,7 @@
       </p:sp>
       <p:sp>
         <p:nvSpPr>
-          <p:cNvPr id="38" name="Liaison gérant"/>
+          <p:cNvPr id="28" name="Liaison gérant"/>
           <p:cNvSpPr/>
           <p:nvPr/>
         </p:nvSpPr>
@@ -5835,7 +5475,7 @@
       </p:sp>
       <p:sp>
         <p:nvSpPr>
-          <p:cNvPr id="39" name="Gérant"/>
+          <p:cNvPr id="29" name="Gérant"/>
           <p:cNvSpPr/>
           <p:nvPr/>
         </p:nvSpPr>
@@ -5862,7 +5502,7 @@
       </p:sp>
       <p:pic>
         <p:nvPicPr>
-          <p:cNvPr id="40" name="Gérant icône" descr="preencoded.png">    </p:cNvPr>
+          <p:cNvPr id="30" name="Gérant icône" descr="preencoded.png">    </p:cNvPr>
           <p:cNvPicPr>
             <a:picLocks noChangeAspect="1"/>
           </p:cNvPicPr>
@@ -5886,7 +5526,7 @@
       </p:pic>
       <p:sp>
         <p:nvSpPr>
-          <p:cNvPr id="41" name="Gérant texte"/>
+          <p:cNvPr id="31" name="Gérant texte"/>
           <p:cNvSpPr txBox="1"/>
           <p:nvPr/>
         </p:nvSpPr>
@@ -5922,7 +5562,7 @@
       </p:sp>
       <p:sp>
         <p:nvSpPr>
-          <p:cNvPr id="42" name="Liaison serveur"/>
+          <p:cNvPr id="32" name="Liaison serveur"/>
           <p:cNvSpPr/>
           <p:nvPr/>
         </p:nvSpPr>
@@ -5945,7 +5585,7 @@
       </p:sp>
       <p:sp>
         <p:nvSpPr>
-          <p:cNvPr id="43" name="Serveur"/>
+          <p:cNvPr id="33" name="Serveur"/>
           <p:cNvSpPr/>
           <p:nvPr/>
         </p:nvSpPr>
@@ -5972,7 +5612,7 @@
       </p:sp>
       <p:pic>
         <p:nvPicPr>
-          <p:cNvPr id="44" name="Serveur icône" descr="preencoded.png">    </p:cNvPr>
+          <p:cNvPr id="34" name="Serveur icône" descr="preencoded.png">    </p:cNvPr>
           <p:cNvPicPr>
             <a:picLocks noChangeAspect="1"/>
           </p:cNvPicPr>
@@ -5996,7 +5636,7 @@
       </p:pic>
       <p:sp>
         <p:nvSpPr>
-          <p:cNvPr id="45" name="Serveur texte"/>
+          <p:cNvPr id="35" name="Serveur texte"/>
           <p:cNvSpPr txBox="1"/>
           <p:nvPr/>
         </p:nvSpPr>
@@ -6046,7 +5686,7 @@
       </p:sp>
       <p:sp>
         <p:nvSpPr>
-          <p:cNvPr id="46" name="Conditions du test"/>
+          <p:cNvPr id="36" name="Conditions du test"/>
           <p:cNvSpPr txBox="1"/>
           <p:nvPr/>
         </p:nvSpPr>
@@ -6751,7 +6391,7 @@
                   <a:schemeClr val="tx1"/>
                 </a:solidFill>
               </a:rPr>
-              <a:t>نحو 5 كيلوبايت من البيانات. عشرة صناديق بالإيقاع الفعلي تستعمل 22 كيلوبت/ث، والشبكة المحلية العادية توفّر 100000 على الأقل.</a:t>
+              <a:t>نحو 5 كيلوبايت من البيانات. كل الصناديق معاً، بالإيقاع الفعلي، تستعمل 22 كيلوبت/ث، والشبكة المحلية العادية توفّر 100000 على الأقل.</a:t>
             </a:r>
             <a:endParaRPr lang="ar-SA" sz="1600" dirty="0"/>
           </a:p>
@@ -7024,7 +6664,7 @@
                   <a:schemeClr val="tx1"/>
                 </a:solidFill>
               </a:rPr>
-              <a:t>10 صناديق تستعمل أقل من 1% من القدرة المقيسة.</a:t>
+              <a:t>متجر كبير متعدد المراكز يستعمل أقل من 1% من القدرة المقيسة.</a:t>
             </a:r>
             <a:endParaRPr lang="ar-SA" sz="1300" dirty="0"/>
           </a:p>
@@ -7060,7 +6700,7 @@
                   <a:schemeClr val="tx1"/>
                 </a:solidFill>
               </a:rPr>
-              <a:t>10 صناديق تبيع السلعة نفسها دون توقف: لا أخطاء، و2,5 ث انتظار في أسوأ الحالات (حالة قصوى).</a:t>
+              <a:t>كل الصناديق تبيع السلعة نفسها دون توقف: لا أخطاء، و2,5 ث انتظار في أسوأ الحالات (حالة قصوى).</a:t>
             </a:r>
             <a:endParaRPr lang="ar-SA" sz="1300" dirty="0"/>
           </a:p>

</xml_diff>